<commit_message>
Add branch-performance slides for all 4 agents
Dudu, Haim, Stas, Chadash — one slide each, top 20 branches by
orthopedic rank with color-flagged status and Kirill's recommendations.
Dudu's slide corrected to show 2025 pace instead of raw 2025 sales.
</commit_message>
<xml_diff>
--- a/svetlana/outputs/2026-08-01-ביצועי-סוכנים-דודו.pptx
+++ b/svetlana/outputs/2026-08-01-ביצועי-סוכנים-דודו.pptx
@@ -1282,7 +1282,7 @@
                           <a:ea typeface="Arial" pitchFamily="34" charset="-122"/>
                           <a:cs typeface="Arial" pitchFamily="34" charset="-120"/>
                         </a:rPr>
-                        <a:t>מכירות 2025</a:t>
+                        <a:t>קצב 2025</a:t>
                       </a:r>
                       <a:endParaRPr lang="en-US" sz="950" dirty="0">
                         <a:latin typeface="Arial" charset="0"/>
@@ -1760,7 +1760,7 @@
                           <a:ea typeface="Arial" pitchFamily="34" charset="-122"/>
                           <a:cs typeface="Arial" pitchFamily="34" charset="-120"/>
                         </a:rPr>
-                        <a:t>70,290</a:t>
+                        <a:t>35,145</a:t>
                       </a:r>
                       <a:endParaRPr lang="en-US" sz="950" dirty="0">
                         <a:latin typeface="Arial" charset="0"/>
@@ -2238,7 +2238,7 @@
                           <a:ea typeface="Arial" pitchFamily="34" charset="-122"/>
                           <a:cs typeface="Arial" pitchFamily="34" charset="-120"/>
                         </a:rPr>
-                        <a:t>52,742</a:t>
+                        <a:t>26,371</a:t>
                       </a:r>
                       <a:endParaRPr lang="en-US" sz="950" dirty="0">
                         <a:latin typeface="Arial" charset="0"/>
@@ -2716,7 +2716,7 @@
                           <a:ea typeface="Arial" pitchFamily="34" charset="-122"/>
                           <a:cs typeface="Arial" pitchFamily="34" charset="-120"/>
                         </a:rPr>
-                        <a:t>63,212</a:t>
+                        <a:t>31,606</a:t>
                       </a:r>
                       <a:endParaRPr lang="en-US" sz="950" dirty="0">
                         <a:latin typeface="Arial" charset="0"/>
@@ -3194,7 +3194,7 @@
                           <a:ea typeface="Arial" pitchFamily="34" charset="-122"/>
                           <a:cs typeface="Arial" pitchFamily="34" charset="-120"/>
                         </a:rPr>
-                        <a:t>46,443</a:t>
+                        <a:t>23,221</a:t>
                       </a:r>
                       <a:endParaRPr lang="en-US" sz="950" dirty="0">
                         <a:latin typeface="Arial" charset="0"/>
@@ -3672,7 +3672,7 @@
                           <a:ea typeface="Arial" pitchFamily="34" charset="-122"/>
                           <a:cs typeface="Arial" pitchFamily="34" charset="-120"/>
                         </a:rPr>
-                        <a:t>50,792</a:t>
+                        <a:t>25,396</a:t>
                       </a:r>
                       <a:endParaRPr lang="en-US" sz="950" dirty="0">
                         <a:latin typeface="Arial" charset="0"/>
@@ -4150,7 +4150,7 @@
                           <a:ea typeface="Arial" pitchFamily="34" charset="-122"/>
                           <a:cs typeface="Arial" pitchFamily="34" charset="-120"/>
                         </a:rPr>
-                        <a:t>51,667</a:t>
+                        <a:t>25,833</a:t>
                       </a:r>
                       <a:endParaRPr lang="en-US" sz="950" dirty="0">
                         <a:latin typeface="Arial" charset="0"/>
@@ -4628,7 +4628,7 @@
                           <a:ea typeface="Arial" pitchFamily="34" charset="-122"/>
                           <a:cs typeface="Arial" pitchFamily="34" charset="-120"/>
                         </a:rPr>
-                        <a:t>39,006</a:t>
+                        <a:t>19,503</a:t>
                       </a:r>
                       <a:endParaRPr lang="en-US" sz="950" dirty="0">
                         <a:latin typeface="Arial" charset="0"/>
@@ -5106,7 +5106,7 @@
                           <a:ea typeface="Arial" pitchFamily="34" charset="-122"/>
                           <a:cs typeface="Arial" pitchFamily="34" charset="-120"/>
                         </a:rPr>
-                        <a:t>52,586</a:t>
+                        <a:t>26,293</a:t>
                       </a:r>
                       <a:endParaRPr lang="en-US" sz="950" dirty="0">
                         <a:latin typeface="Arial" charset="0"/>
@@ -5584,7 +5584,7 @@
                           <a:ea typeface="Arial" pitchFamily="34" charset="-122"/>
                           <a:cs typeface="Arial" pitchFamily="34" charset="-120"/>
                         </a:rPr>
-                        <a:t>56,803</a:t>
+                        <a:t>28,401</a:t>
                       </a:r>
                       <a:endParaRPr lang="en-US" sz="950" dirty="0">
                         <a:latin typeface="Arial" charset="0"/>
@@ -6062,7 +6062,7 @@
                           <a:ea typeface="Arial" pitchFamily="34" charset="-122"/>
                           <a:cs typeface="Arial" pitchFamily="34" charset="-120"/>
                         </a:rPr>
-                        <a:t>58,295</a:t>
+                        <a:t>29,148</a:t>
                       </a:r>
                       <a:endParaRPr lang="en-US" sz="950" dirty="0">
                         <a:latin typeface="Arial" charset="0"/>
@@ -6540,7 +6540,7 @@
                           <a:ea typeface="Arial" pitchFamily="34" charset="-122"/>
                           <a:cs typeface="Arial" pitchFamily="34" charset="-120"/>
                         </a:rPr>
-                        <a:t>46,558</a:t>
+                        <a:t>23,279</a:t>
                       </a:r>
                       <a:endParaRPr lang="en-US" sz="950" dirty="0">
                         <a:latin typeface="Arial" charset="0"/>
@@ -7018,7 +7018,7 @@
                           <a:ea typeface="Arial" pitchFamily="34" charset="-122"/>
                           <a:cs typeface="Arial" pitchFamily="34" charset="-120"/>
                         </a:rPr>
-                        <a:t>36,775</a:t>
+                        <a:t>18,387</a:t>
                       </a:r>
                       <a:endParaRPr lang="en-US" sz="950" dirty="0">
                         <a:latin typeface="Arial" charset="0"/>
@@ -7496,7 +7496,7 @@
                           <a:ea typeface="Arial" pitchFamily="34" charset="-122"/>
                           <a:cs typeface="Arial" pitchFamily="34" charset="-120"/>
                         </a:rPr>
-                        <a:t>36,086</a:t>
+                        <a:t>18,043</a:t>
                       </a:r>
                       <a:endParaRPr lang="en-US" sz="950" dirty="0">
                         <a:latin typeface="Arial" charset="0"/>
@@ -7974,7 +7974,7 @@
                           <a:ea typeface="Arial" pitchFamily="34" charset="-122"/>
                           <a:cs typeface="Arial" pitchFamily="34" charset="-120"/>
                         </a:rPr>
-                        <a:t>35,954</a:t>
+                        <a:t>17,977</a:t>
                       </a:r>
                       <a:endParaRPr lang="en-US" sz="950" dirty="0">
                         <a:latin typeface="Arial" charset="0"/>
@@ -8452,7 +8452,7 @@
                           <a:ea typeface="Arial" pitchFamily="34" charset="-122"/>
                           <a:cs typeface="Arial" pitchFamily="34" charset="-120"/>
                         </a:rPr>
-                        <a:t>40,253</a:t>
+                        <a:t>20,127</a:t>
                       </a:r>
                       <a:endParaRPr lang="en-US" sz="950" dirty="0">
                         <a:latin typeface="Arial" charset="0"/>
@@ -8930,7 +8930,7 @@
                           <a:ea typeface="Arial" pitchFamily="34" charset="-122"/>
                           <a:cs typeface="Arial" pitchFamily="34" charset="-120"/>
                         </a:rPr>
-                        <a:t>29,529</a:t>
+                        <a:t>14,765</a:t>
                       </a:r>
                       <a:endParaRPr lang="en-US" sz="950" dirty="0">
                         <a:latin typeface="Arial" charset="0"/>
@@ -9408,7 +9408,7 @@
                           <a:ea typeface="Arial" pitchFamily="34" charset="-122"/>
                           <a:cs typeface="Arial" pitchFamily="34" charset="-120"/>
                         </a:rPr>
-                        <a:t>28,337</a:t>
+                        <a:t>14,169</a:t>
                       </a:r>
                       <a:endParaRPr lang="en-US" sz="950" dirty="0">
                         <a:latin typeface="Arial" charset="0"/>
@@ -9886,7 +9886,7 @@
                           <a:ea typeface="Arial" pitchFamily="34" charset="-122"/>
                           <a:cs typeface="Arial" pitchFamily="34" charset="-120"/>
                         </a:rPr>
-                        <a:t>42,012</a:t>
+                        <a:t>21,006</a:t>
                       </a:r>
                       <a:endParaRPr lang="en-US" sz="950" dirty="0">
                         <a:latin typeface="Arial" charset="0"/>
@@ -10364,7 +10364,7 @@
                           <a:ea typeface="Arial" pitchFamily="34" charset="-122"/>
                           <a:cs typeface="Arial" pitchFamily="34" charset="-120"/>
                         </a:rPr>
-                        <a:t>37,059</a:t>
+                        <a:t>18,530</a:t>
                       </a:r>
                       <a:endParaRPr lang="en-US" sz="950" dirty="0">
                         <a:latin typeface="Arial" charset="0"/>
@@ -10842,7 +10842,7 @@
                           <a:ea typeface="Arial" pitchFamily="34" charset="-122"/>
                           <a:cs typeface="Arial" pitchFamily="34" charset="-120"/>
                         </a:rPr>
-                        <a:t>45,292</a:t>
+                        <a:t>22,646</a:t>
                       </a:r>
                       <a:endParaRPr lang="en-US" sz="950" dirty="0">
                         <a:latin typeface="Arial" charset="0"/>
@@ -11384,7 +11384,7 @@
         <p:spPr>
           <a:xfrm>
             <a:off x="777240" y="2432304"/>
-            <a:ext cx="3632911" cy="256032"/>
+            <a:ext cx="3632911" cy="292608"/>
           </a:xfrm>
           <a:prstGeom prst="rect">
             <a:avLst/>
@@ -11423,7 +11423,7 @@
         <p:spPr>
           <a:xfrm>
             <a:off x="777240" y="2724912"/>
-            <a:ext cx="3870655" cy="896112"/>
+            <a:ext cx="3870655" cy="683514"/>
           </a:xfrm>
           <a:prstGeom prst="rect">
             <a:avLst/>
@@ -11464,7 +11464,7 @@
         </p:nvSpPr>
         <p:spPr>
           <a:xfrm>
-            <a:off x="4501591" y="3794760"/>
+            <a:off x="4501591" y="3545586"/>
             <a:ext cx="146304" cy="146304"/>
           </a:xfrm>
           <a:prstGeom prst="roundRect">
@@ -11486,8 +11486,8 @@
         </p:nvSpPr>
         <p:spPr>
           <a:xfrm>
-            <a:off x="777240" y="3749040"/>
-            <a:ext cx="3632911" cy="256032"/>
+            <a:off x="777240" y="3499866"/>
+            <a:ext cx="3632911" cy="292608"/>
           </a:xfrm>
           <a:prstGeom prst="rect">
             <a:avLst/>
@@ -11525,8 +11525,8 @@
         </p:nvSpPr>
         <p:spPr>
           <a:xfrm>
-            <a:off x="777240" y="4041648"/>
-            <a:ext cx="3870655" cy="896112"/>
+            <a:off x="777240" y="3792474"/>
+            <a:ext cx="3870655" cy="893064"/>
           </a:xfrm>
           <a:prstGeom prst="rect">
             <a:avLst/>
@@ -11567,7 +11567,7 @@
         </p:nvSpPr>
         <p:spPr>
           <a:xfrm>
-            <a:off x="4501591" y="5111496"/>
+            <a:off x="4501591" y="4822698"/>
             <a:ext cx="146304" cy="146304"/>
           </a:xfrm>
           <a:prstGeom prst="roundRect">
@@ -11589,8 +11589,8 @@
         </p:nvSpPr>
         <p:spPr>
           <a:xfrm>
-            <a:off x="777240" y="5065776"/>
-            <a:ext cx="3632911" cy="256032"/>
+            <a:off x="777240" y="4776978"/>
+            <a:ext cx="3632911" cy="292608"/>
           </a:xfrm>
           <a:prstGeom prst="rect">
             <a:avLst/>
@@ -11628,8 +11628,8 @@
         </p:nvSpPr>
         <p:spPr>
           <a:xfrm>
-            <a:off x="777240" y="5358384"/>
-            <a:ext cx="3870655" cy="896112"/>
+            <a:off x="777240" y="5069586"/>
+            <a:ext cx="3870655" cy="893064"/>
           </a:xfrm>
           <a:prstGeom prst="rect">
             <a:avLst/>

</xml_diff>